<commit_message>
W2 Wed: clarify vague kickers (drop 'map'/'receipts'), engaged discussion slides (provocation + concrete prompts + format/output strip via new discuss template)
Co-Authored-By: Claude Fable 5 <noreply@anthropic.com>
</commit_message>
<xml_diff>
--- a/slides/Week2-Wed-AI-Against-AI.pptx
+++ b/slides/Week2-Wed-AI-Against-AI.pptx
@@ -1227,7 +1227,7 @@
           <a:lstStyle/>
           <a:p>
             <a:r>
-              <a:t>Return to the fightback idea they jotted at the start. Now they DECIDE: is that the thing they build for Part B? Seed with the counter-map + deep dives if stuck. A few shout one out; map each to a value. This is the hand-off into the activity.</a:t>
+              <a:t>Callback to the warm-up they held onto. This is the decision point — everyone leaves this slide with one buildable idea. Take a few out loud to seed the room. Hand-off into the activity.</a:t>
             </a:r>
           </a:p>
         </p:txBody>
@@ -1297,7 +1297,7 @@
           <a:lstStyle/>
           <a:p>
             <a:r>
-              <a:t>Everyone jots 1–2 on paper / a sticky. No wrong answers — activate what they already know before the lecture enriches it. Tell them: hold onto your fightback idea — you can BUILD it as your Part B project this afternoon. We come back to these before the activity.</a:t>
+              <a:t>Personal and visceral on purpose — pull from their own life, not the abstract. No wrong answers. We return to these ideas right before the build; the fightback becomes a candidate Part B project.</a:t>
             </a:r>
           </a:p>
         </p:txBody>
@@ -2067,7 +2067,7 @@
           <a:lstStyle/>
           <a:p>
             <a:r>
-              <a:t>Turn-to-your-neighbor. Surfaces the value each student cares about — which becomes the lens for their defense/Part B. Take 2–3 out loud, map each to the red grid.</a:t>
+              <a:t>Forcing a single choice + pairing with someone who disagreed creates real engagement (a mini-debate, not a vague 'thoughts?'). The value they defend here becomes the lens for their Part B.</a:t>
             </a:r>
           </a:p>
         </p:txBody>
@@ -5302,7 +5302,7 @@
                 </a:solidFill>
                 <a:latin typeface="Courier New"/>
               </a:rPr>
-              <a:t>NOT HYPOTHETICAL · THE HIDDEN COSTS</a:t>
+              <a:t>REAL CASES · THE HIDDEN COSTS</a:t>
             </a:r>
           </a:p>
         </p:txBody>
@@ -5700,25 +5700,69 @@
             <a:r>
               <a:rPr sz="1300" b="1">
                 <a:solidFill>
-                  <a:srgbClr val="00FF41"/>
+                  <a:srgbClr val="FF4D4D"/>
                 </a:solidFill>
                 <a:latin typeface="Courier New"/>
               </a:rPr>
-              <a:t>TALK · 3 MIN</a:t>
-            </a:r>
-          </a:p>
-        </p:txBody>
-      </p:sp>
-      <p:sp>
-        <p:nvSpPr>
-          <p:cNvPr id="3" name="TextBox 2"/>
+              <a:t>TAKE A SIDE · 3 MIN</a:t>
+            </a:r>
+          </a:p>
+        </p:txBody>
+      </p:sp>
+      <p:sp>
+        <p:nvSpPr>
+          <p:cNvPr id="3" name="Rectangle 2"/>
+          <p:cNvSpPr/>
+          <p:nvPr/>
+        </p:nvSpPr>
+        <p:spPr>
+          <a:xfrm>
+            <a:off x="640080" y="932688"/>
+            <a:ext cx="822960" cy="73152"/>
+          </a:xfrm>
+          <a:prstGeom prst="rect">
+            <a:avLst/>
+          </a:prstGeom>
+          <a:solidFill>
+            <a:srgbClr val="FF4D4D"/>
+          </a:solidFill>
+          <a:ln>
+            <a:noFill/>
+          </a:ln>
+          <a:effectLst/>
+        </p:spPr>
+        <p:style>
+          <a:lnRef idx="1">
+            <a:schemeClr val="accent1"/>
+          </a:lnRef>
+          <a:fillRef idx="3">
+            <a:schemeClr val="accent1"/>
+          </a:fillRef>
+          <a:effectRef idx="2">
+            <a:schemeClr val="accent1"/>
+          </a:effectRef>
+          <a:fontRef idx="minor">
+            <a:schemeClr val="lt1"/>
+          </a:fontRef>
+        </p:style>
+        <p:txBody>
+          <a:bodyPr rtlCol="0" anchor="ctr"/>
+          <a:lstStyle/>
+          <a:p>
+            <a:pPr algn="ctr"/>
+          </a:p>
+        </p:txBody>
+      </p:sp>
+      <p:sp>
+        <p:nvSpPr>
+          <p:cNvPr id="4" name="TextBox 3"/>
           <p:cNvSpPr txBox="1"/>
           <p:nvPr/>
         </p:nvSpPr>
         <p:spPr>
           <a:xfrm>
-            <a:off x="1097280" y="548640"/>
-            <a:ext cx="2743200" cy="1828800"/>
+            <a:off x="640080" y="1325880"/>
+            <a:ext cx="10972800" cy="1828800"/>
           </a:xfrm>
           <a:prstGeom prst="rect">
             <a:avLst/>
@@ -5733,31 +5777,31 @@
           <a:p>
             <a:pPr algn="l">
               <a:lnSpc>
-                <a:spcPct val="100000"/>
-              </a:lnSpc>
-            </a:pPr>
-            <a:r>
-              <a:rPr sz="12000" b="1">
-                <a:solidFill>
-                  <a:srgbClr val="00FF41"/>
-                </a:solidFill>
-                <a:latin typeface="Arial"/>
-              </a:rPr>
-              <a:t>?</a:t>
-            </a:r>
-          </a:p>
-        </p:txBody>
-      </p:sp>
-      <p:sp>
-        <p:nvSpPr>
-          <p:cNvPr id="4" name="TextBox 3"/>
+                <a:spcPct val="105000"/>
+              </a:lnSpc>
+            </a:pPr>
+            <a:r>
+              <a:rPr sz="3800" b="1">
+                <a:solidFill>
+                  <a:srgbClr val="F5F7FA"/>
+                </a:solidFill>
+                <a:latin typeface="Arial"/>
+              </a:rPr>
+              <a:t>Which harm scares you most?</a:t>
+            </a:r>
+          </a:p>
+        </p:txBody>
+      </p:sp>
+      <p:sp>
+        <p:nvSpPr>
+          <p:cNvPr id="5" name="TextBox 4"/>
           <p:cNvSpPr txBox="1"/>
           <p:nvPr/>
         </p:nvSpPr>
         <p:spPr>
           <a:xfrm>
-            <a:off x="1097280" y="2743200"/>
-            <a:ext cx="10058400" cy="3108960"/>
+            <a:off x="658368" y="3611880"/>
+            <a:ext cx="10972800" cy="1737360"/>
           </a:xfrm>
           <a:prstGeom prst="rect">
             <a:avLst/>
@@ -5772,40 +5816,152 @@
           <a:p>
             <a:pPr algn="l">
               <a:lnSpc>
-                <a:spcPct val="112000"/>
-              </a:lnSpc>
-            </a:pPr>
-            <a:r>
-              <a:rPr sz="3000" b="1">
+                <a:spcPct val="135000"/>
+              </a:lnSpc>
+            </a:pPr>
+            <a:r>
+              <a:rPr sz="1900" b="1">
+                <a:solidFill>
+                  <a:srgbClr val="FF4D4D"/>
+                </a:solidFill>
+                <a:latin typeface="Arial"/>
+              </a:rPr>
+              <a:t>→  </a:t>
+            </a:r>
+            <a:r>
+              <a:rPr sz="1900" b="0">
+                <a:solidFill>
+                  <a:srgbClr val="8A94A6"/>
+                </a:solidFill>
+                <a:latin typeface="Arial"/>
+              </a:rPr>
+              <a:t>Pick ONE of the seven — the one you’d least want done to you or someone you love.</a:t>
+            </a:r>
+          </a:p>
+          <a:p>
+            <a:pPr algn="l">
+              <a:lnSpc>
+                <a:spcPct val="135000"/>
+              </a:lnSpc>
+            </a:pPr>
+            <a:r>
+              <a:rPr sz="1900" b="1">
+                <a:solidFill>
+                  <a:srgbClr val="FF4D4D"/>
+                </a:solidFill>
+                <a:latin typeface="Arial"/>
+              </a:rPr>
+              <a:t>→  </a:t>
+            </a:r>
+            <a:r>
+              <a:rPr sz="1900" b="0">
+                <a:solidFill>
+                  <a:srgbClr val="8A94A6"/>
+                </a:solidFill>
+                <a:latin typeface="Arial"/>
+              </a:rPr>
+              <a:t>Find a neighbor who picked a different one. Defend yours; hear theirs.</a:t>
+            </a:r>
+          </a:p>
+        </p:txBody>
+      </p:sp>
+      <p:sp>
+        <p:nvSpPr>
+          <p:cNvPr id="6" name="Rounded Rectangle 5"/>
+          <p:cNvSpPr/>
+          <p:nvPr/>
+        </p:nvSpPr>
+        <p:spPr>
+          <a:xfrm>
+            <a:off x="640080" y="5532120"/>
+            <a:ext cx="10911535" cy="658368"/>
+          </a:xfrm>
+          <a:prstGeom prst="roundRect">
+            <a:avLst/>
+          </a:prstGeom>
+          <a:solidFill>
+            <a:srgbClr val="151B26"/>
+          </a:solidFill>
+          <a:ln w="19050">
+            <a:solidFill>
+              <a:srgbClr val="FF4D4D"/>
+            </a:solidFill>
+          </a:ln>
+          <a:effectLst/>
+        </p:spPr>
+        <p:style>
+          <a:lnRef idx="1">
+            <a:schemeClr val="accent1"/>
+          </a:lnRef>
+          <a:fillRef idx="3">
+            <a:schemeClr val="accent1"/>
+          </a:fillRef>
+          <a:effectRef idx="2">
+            <a:schemeClr val="accent1"/>
+          </a:effectRef>
+          <a:fontRef idx="minor">
+            <a:schemeClr val="lt1"/>
+          </a:fontRef>
+        </p:style>
+        <p:txBody>
+          <a:bodyPr rtlCol="0" anchor="ctr"/>
+          <a:lstStyle/>
+          <a:p>
+            <a:pPr algn="ctr"/>
+          </a:p>
+        </p:txBody>
+      </p:sp>
+      <p:sp>
+        <p:nvSpPr>
+          <p:cNvPr id="7" name="TextBox 6"/>
+          <p:cNvSpPr txBox="1"/>
+          <p:nvPr/>
+        </p:nvSpPr>
+        <p:spPr>
+          <a:xfrm>
+            <a:off x="914400" y="5532120"/>
+            <a:ext cx="10362895" cy="658368"/>
+          </a:xfrm>
+          <a:prstGeom prst="rect">
+            <a:avLst/>
+          </a:prstGeom>
+          <a:noFill/>
+        </p:spPr>
+        <p:txBody>
+          <a:bodyPr wrap="square" anchor="ctr">
+            <a:spAutoFit/>
+          </a:bodyPr>
+          <a:lstStyle/>
+          <a:p>
+            <a:pPr algn="l">
+              <a:lnSpc>
+                <a:spcPct val="100000"/>
+              </a:lnSpc>
+            </a:pPr>
+            <a:r>
+              <a:rPr sz="1600" b="1">
+                <a:solidFill>
+                  <a:srgbClr val="FF4D4D"/>
+                </a:solidFill>
+                <a:latin typeface="Arial"/>
+              </a:rPr>
+              <a:t>▶  </a:t>
+            </a:r>
+            <a:r>
+              <a:rPr sz="1600" b="1">
                 <a:solidFill>
                   <a:srgbClr val="F5F7FA"/>
                 </a:solidFill>
                 <a:latin typeface="Arial"/>
               </a:rPr>
-              <a:t>Which of these hits closest to home?</a:t>
-            </a:r>
-          </a:p>
-          <a:p>
-            <a:pPr algn="l">
-              <a:lnSpc>
-                <a:spcPct val="112000"/>
-              </a:lnSpc>
-            </a:pPr>
-            <a:r>
-              <a:rPr sz="3000" b="1">
-                <a:solidFill>
-                  <a:srgbClr val="F5F7FA"/>
-                </a:solidFill>
-                <a:latin typeface="Arial"/>
-              </a:rPr>
-              <a:t>Which value would YOU most want to protect?</a:t>
-            </a:r>
-          </a:p>
-        </p:txBody>
-      </p:sp>
-      <p:sp>
-        <p:nvSpPr>
-          <p:cNvPr id="5" name="TextBox 4"/>
+              <a:t>3 min in pairs → we take three to the room. Your pick is the value you’ll defend all afternoon.</a:t>
+            </a:r>
+          </a:p>
+        </p:txBody>
+      </p:sp>
+      <p:sp>
+        <p:nvSpPr>
+          <p:cNvPr id="8" name="TextBox 7"/>
           <p:cNvSpPr txBox="1"/>
           <p:nvPr/>
         </p:nvSpPr>
@@ -5902,7 +6058,7 @@
                 </a:solidFill>
                 <a:latin typeface="Courier New"/>
               </a:rPr>
-              <a:t>THE TURN</a:t>
+              <a:t>FROM PROBLEM TO DEFENSE</a:t>
             </a:r>
           </a:p>
         </p:txBody>
@@ -6104,7 +6260,7 @@
                 </a:solidFill>
                 <a:latin typeface="Arial"/>
               </a:rPr>
-              <a:t>For every harm on that map — is there a defense?</a:t>
+              <a:t>For every harm we just saw — is there a defense?</a:t>
             </a:r>
           </a:p>
         </p:txBody>
@@ -6395,7 +6551,7 @@
                 </a:solidFill>
                 <a:latin typeface="Courier New"/>
               </a:rPr>
-              <a:t>THE COUNTER-MAP · DEFENSES</a:t>
+              <a:t>DEFENSES · ONE PER VALUE</a:t>
             </a:r>
           </a:p>
         </p:txBody>
@@ -9742,7 +9898,7 @@
                 </a:solidFill>
                 <a:latin typeface="Courier New"/>
               </a:rPr>
-              <a:t>THE CATCH</a:t>
+              <a:t>A REALITY CHECK</a:t>
             </a:r>
           </a:p>
         </p:txBody>
@@ -9940,21 +10096,65 @@
                 </a:solidFill>
                 <a:latin typeface="Courier New"/>
               </a:rPr>
-              <a:t>BACK TO YOUR WARM-UP</a:t>
-            </a:r>
-          </a:p>
-        </p:txBody>
-      </p:sp>
-      <p:sp>
-        <p:nvSpPr>
-          <p:cNvPr id="3" name="TextBox 2"/>
+              <a:t>DECIDE · YOUR PART B</a:t>
+            </a:r>
+          </a:p>
+        </p:txBody>
+      </p:sp>
+      <p:sp>
+        <p:nvSpPr>
+          <p:cNvPr id="3" name="Rectangle 2"/>
+          <p:cNvSpPr/>
+          <p:nvPr/>
+        </p:nvSpPr>
+        <p:spPr>
+          <a:xfrm>
+            <a:off x="640080" y="932688"/>
+            <a:ext cx="822960" cy="73152"/>
+          </a:xfrm>
+          <a:prstGeom prst="rect">
+            <a:avLst/>
+          </a:prstGeom>
+          <a:solidFill>
+            <a:srgbClr val="00FF41"/>
+          </a:solidFill>
+          <a:ln>
+            <a:noFill/>
+          </a:ln>
+          <a:effectLst/>
+        </p:spPr>
+        <p:style>
+          <a:lnRef idx="1">
+            <a:schemeClr val="accent1"/>
+          </a:lnRef>
+          <a:fillRef idx="3">
+            <a:schemeClr val="accent1"/>
+          </a:fillRef>
+          <a:effectRef idx="2">
+            <a:schemeClr val="accent1"/>
+          </a:effectRef>
+          <a:fontRef idx="minor">
+            <a:schemeClr val="lt1"/>
+          </a:fontRef>
+        </p:style>
+        <p:txBody>
+          <a:bodyPr rtlCol="0" anchor="ctr"/>
+          <a:lstStyle/>
+          <a:p>
+            <a:pPr algn="ctr"/>
+          </a:p>
+        </p:txBody>
+      </p:sp>
+      <p:sp>
+        <p:nvSpPr>
+          <p:cNvPr id="4" name="TextBox 3"/>
           <p:cNvSpPr txBox="1"/>
           <p:nvPr/>
         </p:nvSpPr>
         <p:spPr>
           <a:xfrm>
-            <a:off x="1097280" y="548640"/>
-            <a:ext cx="2743200" cy="1828800"/>
+            <a:off x="640080" y="1325880"/>
+            <a:ext cx="10972800" cy="1828800"/>
           </a:xfrm>
           <a:prstGeom prst="rect">
             <a:avLst/>
@@ -9969,31 +10169,31 @@
           <a:p>
             <a:pPr algn="l">
               <a:lnSpc>
-                <a:spcPct val="100000"/>
-              </a:lnSpc>
-            </a:pPr>
-            <a:r>
-              <a:rPr sz="12000" b="1">
-                <a:solidFill>
-                  <a:srgbClr val="00FF41"/>
-                </a:solidFill>
-                <a:latin typeface="Arial"/>
-              </a:rPr>
-              <a:t>?</a:t>
-            </a:r>
-          </a:p>
-        </p:txBody>
-      </p:sp>
-      <p:sp>
-        <p:nvSpPr>
-          <p:cNvPr id="4" name="TextBox 3"/>
+                <a:spcPct val="105000"/>
+              </a:lnSpc>
+            </a:pPr>
+            <a:r>
+              <a:rPr sz="3800" b="1">
+                <a:solidFill>
+                  <a:srgbClr val="F5F7FA"/>
+                </a:solidFill>
+                <a:latin typeface="Arial"/>
+              </a:rPr>
+              <a:t>That fightback idea from this morning — build it?</a:t>
+            </a:r>
+          </a:p>
+        </p:txBody>
+      </p:sp>
+      <p:sp>
+        <p:nvSpPr>
+          <p:cNvPr id="5" name="TextBox 4"/>
           <p:cNvSpPr txBox="1"/>
           <p:nvPr/>
         </p:nvSpPr>
         <p:spPr>
           <a:xfrm>
-            <a:off x="1097280" y="2743200"/>
-            <a:ext cx="10058400" cy="3108960"/>
+            <a:off x="658368" y="3611880"/>
+            <a:ext cx="10972800" cy="1737360"/>
           </a:xfrm>
           <a:prstGeom prst="rect">
             <a:avLst/>
@@ -10008,40 +10208,177 @@
           <a:p>
             <a:pPr algn="l">
               <a:lnSpc>
-                <a:spcPct val="112000"/>
-              </a:lnSpc>
-            </a:pPr>
-            <a:r>
-              <a:rPr sz="3000" b="1">
+                <a:spcPct val="135000"/>
+              </a:lnSpc>
+            </a:pPr>
+            <a:r>
+              <a:rPr sz="1900" b="1">
+                <a:solidFill>
+                  <a:srgbClr val="00FF41"/>
+                </a:solidFill>
+                <a:latin typeface="Arial"/>
+              </a:rPr>
+              <a:t>→  </a:t>
+            </a:r>
+            <a:r>
+              <a:rPr sz="1900" b="0">
+                <a:solidFill>
+                  <a:srgbClr val="8A94A6"/>
+                </a:solidFill>
+                <a:latin typeface="Arial"/>
+              </a:rPr>
+              <a:t>Too big? Cut it to one page you can finish and demo today.</a:t>
+            </a:r>
+          </a:p>
+          <a:p>
+            <a:pPr algn="l">
+              <a:lnSpc>
+                <a:spcPct val="135000"/>
+              </a:lnSpc>
+            </a:pPr>
+            <a:r>
+              <a:rPr sz="1900" b="1">
+                <a:solidFill>
+                  <a:srgbClr val="00FF41"/>
+                </a:solidFill>
+                <a:latin typeface="Arial"/>
+              </a:rPr>
+              <a:t>→  </a:t>
+            </a:r>
+            <a:r>
+              <a:rPr sz="1900" b="0">
+                <a:solidFill>
+                  <a:srgbClr val="8A94A6"/>
+                </a:solidFill>
+                <a:latin typeface="Arial"/>
+              </a:rPr>
+              <a:t>No idea, or it fizzled? Steal one from the green side, or defend the value you argued for.</a:t>
+            </a:r>
+          </a:p>
+          <a:p>
+            <a:pPr algn="l">
+              <a:lnSpc>
+                <a:spcPct val="135000"/>
+              </a:lnSpc>
+            </a:pPr>
+            <a:r>
+              <a:rPr sz="1900" b="1">
+                <a:solidFill>
+                  <a:srgbClr val="00FF41"/>
+                </a:solidFill>
+                <a:latin typeface="Arial"/>
+              </a:rPr>
+              <a:t>→  </a:t>
+            </a:r>
+            <a:r>
+              <a:rPr sz="1900" b="0">
+                <a:solidFill>
+                  <a:srgbClr val="8A94A6"/>
+                </a:solidFill>
+                <a:latin typeface="Arial"/>
+              </a:rPr>
+              <a:t>Still stuck? Pair up — two people, one defense.</a:t>
+            </a:r>
+          </a:p>
+        </p:txBody>
+      </p:sp>
+      <p:sp>
+        <p:nvSpPr>
+          <p:cNvPr id="6" name="Rounded Rectangle 5"/>
+          <p:cNvSpPr/>
+          <p:nvPr/>
+        </p:nvSpPr>
+        <p:spPr>
+          <a:xfrm>
+            <a:off x="640080" y="5532120"/>
+            <a:ext cx="10911535" cy="658368"/>
+          </a:xfrm>
+          <a:prstGeom prst="roundRect">
+            <a:avLst/>
+          </a:prstGeom>
+          <a:solidFill>
+            <a:srgbClr val="151B26"/>
+          </a:solidFill>
+          <a:ln w="19050">
+            <a:solidFill>
+              <a:srgbClr val="00FF41"/>
+            </a:solidFill>
+          </a:ln>
+          <a:effectLst/>
+        </p:spPr>
+        <p:style>
+          <a:lnRef idx="1">
+            <a:schemeClr val="accent1"/>
+          </a:lnRef>
+          <a:fillRef idx="3">
+            <a:schemeClr val="accent1"/>
+          </a:fillRef>
+          <a:effectRef idx="2">
+            <a:schemeClr val="accent1"/>
+          </a:effectRef>
+          <a:fontRef idx="minor">
+            <a:schemeClr val="lt1"/>
+          </a:fontRef>
+        </p:style>
+        <p:txBody>
+          <a:bodyPr rtlCol="0" anchor="ctr"/>
+          <a:lstStyle/>
+          <a:p>
+            <a:pPr algn="ctr"/>
+          </a:p>
+        </p:txBody>
+      </p:sp>
+      <p:sp>
+        <p:nvSpPr>
+          <p:cNvPr id="7" name="TextBox 6"/>
+          <p:cNvSpPr txBox="1"/>
+          <p:nvPr/>
+        </p:nvSpPr>
+        <p:spPr>
+          <a:xfrm>
+            <a:off x="914400" y="5532120"/>
+            <a:ext cx="10362895" cy="658368"/>
+          </a:xfrm>
+          <a:prstGeom prst="rect">
+            <a:avLst/>
+          </a:prstGeom>
+          <a:noFill/>
+        </p:spPr>
+        <p:txBody>
+          <a:bodyPr wrap="square" anchor="ctr">
+            <a:spAutoFit/>
+          </a:bodyPr>
+          <a:lstStyle/>
+          <a:p>
+            <a:pPr algn="l">
+              <a:lnSpc>
+                <a:spcPct val="100000"/>
+              </a:lnSpc>
+            </a:pPr>
+            <a:r>
+              <a:rPr sz="1600" b="1">
+                <a:solidFill>
+                  <a:srgbClr val="00FF41"/>
+                </a:solidFill>
+                <a:latin typeface="Arial"/>
+              </a:rPr>
+              <a:t>▶  </a:t>
+            </a:r>
+            <a:r>
+              <a:rPr sz="1600" b="1">
                 <a:solidFill>
                   <a:srgbClr val="F5F7FA"/>
                 </a:solidFill>
                 <a:latin typeface="Arial"/>
               </a:rPr>
-              <a:t>Pick a harm from the red map —</a:t>
-            </a:r>
-          </a:p>
-          <a:p>
-            <a:pPr algn="l">
-              <a:lnSpc>
-                <a:spcPct val="112000"/>
-              </a:lnSpc>
-            </a:pPr>
-            <a:r>
-              <a:rPr sz="3000" b="1">
-                <a:solidFill>
-                  <a:srgbClr val="F5F7FA"/>
-                </a:solidFill>
-                <a:latin typeface="Arial"/>
-              </a:rPr>
-              <a:t>your defense becomes your Part B. Build it.</a:t>
-            </a:r>
-          </a:p>
-        </p:txBody>
-      </p:sp>
-      <p:sp>
-        <p:nvSpPr>
-          <p:cNvPr id="5" name="TextBox 4"/>
+              <a:t>Commit to ONE in 3 min. That’s your Part B. Then we build.</a:t>
+            </a:r>
+          </a:p>
+        </p:txBody>
+      </p:sp>
+      <p:sp>
+        <p:nvSpPr>
+          <p:cNvPr id="8" name="TextBox 7"/>
           <p:cNvSpPr txBox="1"/>
           <p:nvPr/>
         </p:nvSpPr>
@@ -11039,7 +11376,7 @@
                 </a:solidFill>
                 <a:latin typeface="Arial"/>
               </a:rPr>
-              <a:t>Where the map comes from</a:t>
+              <a:t>Where this comes from</a:t>
             </a:r>
           </a:p>
         </p:txBody>
@@ -11287,7 +11624,7 @@
             <a:r>
               <a:rPr sz="1300" b="1">
                 <a:solidFill>
-                  <a:srgbClr val="00FF41"/>
+                  <a:srgbClr val="FF4D4D"/>
                 </a:solidFill>
                 <a:latin typeface="Courier New"/>
               </a:rPr>
@@ -11298,14 +11635,58 @@
       </p:sp>
       <p:sp>
         <p:nvSpPr>
-          <p:cNvPr id="3" name="TextBox 2"/>
+          <p:cNvPr id="3" name="Rectangle 2"/>
+          <p:cNvSpPr/>
+          <p:nvPr/>
+        </p:nvSpPr>
+        <p:spPr>
+          <a:xfrm>
+            <a:off x="640080" y="932688"/>
+            <a:ext cx="822960" cy="73152"/>
+          </a:xfrm>
+          <a:prstGeom prst="rect">
+            <a:avLst/>
+          </a:prstGeom>
+          <a:solidFill>
+            <a:srgbClr val="FF4D4D"/>
+          </a:solidFill>
+          <a:ln>
+            <a:noFill/>
+          </a:ln>
+          <a:effectLst/>
+        </p:spPr>
+        <p:style>
+          <a:lnRef idx="1">
+            <a:schemeClr val="accent1"/>
+          </a:lnRef>
+          <a:fillRef idx="3">
+            <a:schemeClr val="accent1"/>
+          </a:fillRef>
+          <a:effectRef idx="2">
+            <a:schemeClr val="accent1"/>
+          </a:effectRef>
+          <a:fontRef idx="minor">
+            <a:schemeClr val="lt1"/>
+          </a:fontRef>
+        </p:style>
+        <p:txBody>
+          <a:bodyPr rtlCol="0" anchor="ctr"/>
+          <a:lstStyle/>
+          <a:p>
+            <a:pPr algn="ctr"/>
+          </a:p>
+        </p:txBody>
+      </p:sp>
+      <p:sp>
+        <p:nvSpPr>
+          <p:cNvPr id="4" name="TextBox 3"/>
           <p:cNvSpPr txBox="1"/>
           <p:nvPr/>
         </p:nvSpPr>
         <p:spPr>
           <a:xfrm>
-            <a:off x="1097280" y="548640"/>
-            <a:ext cx="2743200" cy="1828800"/>
+            <a:off x="640080" y="1325880"/>
+            <a:ext cx="10972800" cy="1828800"/>
           </a:xfrm>
           <a:prstGeom prst="rect">
             <a:avLst/>
@@ -11320,31 +11701,31 @@
           <a:p>
             <a:pPr algn="l">
               <a:lnSpc>
-                <a:spcPct val="100000"/>
-              </a:lnSpc>
-            </a:pPr>
-            <a:r>
-              <a:rPr sz="12000" b="1">
-                <a:solidFill>
-                  <a:srgbClr val="00FF41"/>
-                </a:solidFill>
-                <a:latin typeface="Arial"/>
-              </a:rPr>
-              <a:t>?</a:t>
-            </a:r>
-          </a:p>
-        </p:txBody>
-      </p:sp>
-      <p:sp>
-        <p:nvSpPr>
-          <p:cNvPr id="4" name="TextBox 3"/>
+                <a:spcPct val="105000"/>
+              </a:lnSpc>
+            </a:pPr>
+            <a:r>
+              <a:rPr sz="3800" b="1">
+                <a:solidFill>
+                  <a:srgbClr val="F5F7FA"/>
+                </a:solidFill>
+                <a:latin typeface="Arial"/>
+              </a:rPr>
+              <a:t>When did AI last unsettle you?</a:t>
+            </a:r>
+          </a:p>
+        </p:txBody>
+      </p:sp>
+      <p:sp>
+        <p:nvSpPr>
+          <p:cNvPr id="5" name="TextBox 4"/>
           <p:cNvSpPr txBox="1"/>
           <p:nvPr/>
         </p:nvSpPr>
         <p:spPr>
           <a:xfrm>
-            <a:off x="1097280" y="2743200"/>
-            <a:ext cx="10058400" cy="3108960"/>
+            <a:off x="658368" y="3611880"/>
+            <a:ext cx="10972800" cy="1737360"/>
           </a:xfrm>
           <a:prstGeom prst="rect">
             <a:avLst/>
@@ -11359,40 +11740,152 @@
           <a:p>
             <a:pPr algn="l">
               <a:lnSpc>
-                <a:spcPct val="112000"/>
-              </a:lnSpc>
-            </a:pPr>
-            <a:r>
-              <a:rPr sz="3000" b="1">
+                <a:spcPct val="135000"/>
+              </a:lnSpc>
+            </a:pPr>
+            <a:r>
+              <a:rPr sz="1900" b="1">
+                <a:solidFill>
+                  <a:srgbClr val="FF4D4D"/>
+                </a:solidFill>
+                <a:latin typeface="Arial"/>
+              </a:rPr>
+              <a:t>→  </a:t>
+            </a:r>
+            <a:r>
+              <a:rPr sz="1900" b="0">
+                <a:solidFill>
+                  <a:srgbClr val="8A94A6"/>
+                </a:solidFill>
+                <a:latin typeface="Arial"/>
+              </a:rPr>
+              <a:t>Creeped you out, cost someone a job, got a fact wrong that mattered, or felt unfair?</a:t>
+            </a:r>
+          </a:p>
+          <a:p>
+            <a:pPr algn="l">
+              <a:lnSpc>
+                <a:spcPct val="135000"/>
+              </a:lnSpc>
+            </a:pPr>
+            <a:r>
+              <a:rPr sz="1900" b="1">
+                <a:solidFill>
+                  <a:srgbClr val="FF4D4D"/>
+                </a:solidFill>
+                <a:latin typeface="Arial"/>
+              </a:rPr>
+              <a:t>→  </a:t>
+            </a:r>
+            <a:r>
+              <a:rPr sz="1900" b="0">
+                <a:solidFill>
+                  <a:srgbClr val="8A94A6"/>
+                </a:solidFill>
+                <a:latin typeface="Arial"/>
+              </a:rPr>
+              <a:t>Jot ONE harm — and one way you’d fight back against it.</a:t>
+            </a:r>
+          </a:p>
+        </p:txBody>
+      </p:sp>
+      <p:sp>
+        <p:nvSpPr>
+          <p:cNvPr id="6" name="Rounded Rectangle 5"/>
+          <p:cNvSpPr/>
+          <p:nvPr/>
+        </p:nvSpPr>
+        <p:spPr>
+          <a:xfrm>
+            <a:off x="640080" y="5532120"/>
+            <a:ext cx="10911535" cy="658368"/>
+          </a:xfrm>
+          <a:prstGeom prst="roundRect">
+            <a:avLst/>
+          </a:prstGeom>
+          <a:solidFill>
+            <a:srgbClr val="151B26"/>
+          </a:solidFill>
+          <a:ln w="19050">
+            <a:solidFill>
+              <a:srgbClr val="FF4D4D"/>
+            </a:solidFill>
+          </a:ln>
+          <a:effectLst/>
+        </p:spPr>
+        <p:style>
+          <a:lnRef idx="1">
+            <a:schemeClr val="accent1"/>
+          </a:lnRef>
+          <a:fillRef idx="3">
+            <a:schemeClr val="accent1"/>
+          </a:fillRef>
+          <a:effectRef idx="2">
+            <a:schemeClr val="accent1"/>
+          </a:effectRef>
+          <a:fontRef idx="minor">
+            <a:schemeClr val="lt1"/>
+          </a:fontRef>
+        </p:style>
+        <p:txBody>
+          <a:bodyPr rtlCol="0" anchor="ctr"/>
+          <a:lstStyle/>
+          <a:p>
+            <a:pPr algn="ctr"/>
+          </a:p>
+        </p:txBody>
+      </p:sp>
+      <p:sp>
+        <p:nvSpPr>
+          <p:cNvPr id="7" name="TextBox 6"/>
+          <p:cNvSpPr txBox="1"/>
+          <p:nvPr/>
+        </p:nvSpPr>
+        <p:spPr>
+          <a:xfrm>
+            <a:off x="914400" y="5532120"/>
+            <a:ext cx="10362895" cy="658368"/>
+          </a:xfrm>
+          <a:prstGeom prst="rect">
+            <a:avLst/>
+          </a:prstGeom>
+          <a:noFill/>
+        </p:spPr>
+        <p:txBody>
+          <a:bodyPr wrap="square" anchor="ctr">
+            <a:spAutoFit/>
+          </a:bodyPr>
+          <a:lstStyle/>
+          <a:p>
+            <a:pPr algn="l">
+              <a:lnSpc>
+                <a:spcPct val="100000"/>
+              </a:lnSpc>
+            </a:pPr>
+            <a:r>
+              <a:rPr sz="1600" b="1">
+                <a:solidFill>
+                  <a:srgbClr val="FF4D4D"/>
+                </a:solidFill>
+                <a:latin typeface="Arial"/>
+              </a:rPr>
+              <a:t>▶  </a:t>
+            </a:r>
+            <a:r>
+              <a:rPr sz="1600" b="1">
                 <a:solidFill>
                   <a:srgbClr val="F5F7FA"/>
                 </a:solidFill>
                 <a:latin typeface="Arial"/>
               </a:rPr>
-              <a:t>Name one AI harm you’ve felt or seen —</a:t>
-            </a:r>
-          </a:p>
-          <a:p>
-            <a:pPr algn="l">
-              <a:lnSpc>
-                <a:spcPct val="112000"/>
-              </a:lnSpc>
-            </a:pPr>
-            <a:r>
-              <a:rPr sz="3000" b="1">
-                <a:solidFill>
-                  <a:srgbClr val="F5F7FA"/>
-                </a:solidFill>
-                <a:latin typeface="Arial"/>
-              </a:rPr>
-              <a:t>and one way you’d fight back. Keep it.</a:t>
-            </a:r>
-          </a:p>
-        </p:txBody>
-      </p:sp>
-      <p:sp>
-        <p:nvSpPr>
-          <p:cNvPr id="5" name="TextBox 4"/>
+              <a:t>2 min solo, on paper. Keep your fightback idea — you may BUILD it as your Part B this afternoon.</a:t>
+            </a:r>
+          </a:p>
+        </p:txBody>
+      </p:sp>
+      <p:sp>
+        <p:nvSpPr>
+          <p:cNvPr id="8" name="TextBox 7"/>
           <p:cNvSpPr txBox="1"/>
           <p:nvPr/>
         </p:nvSpPr>
@@ -11611,7 +12104,7 @@
                 </a:solidFill>
                 <a:latin typeface="Arial"/>
               </a:rPr>
-              <a:t>A map of the values AI puts under threat — then the receipts.</a:t>
+              <a:t>An overview of the seven values AI puts at risk — then the real cases.</a:t>
             </a:r>
           </a:p>
         </p:txBody>
@@ -11676,7 +12169,7 @@
                 </a:solidFill>
                 <a:latin typeface="Courier New"/>
               </a:rPr>
-              <a:t>THE MAP · VALUES UNDER THREAT</a:t>
+              <a:t>OVERVIEW · SEVEN VALUES AT RISK</a:t>
             </a:r>
           </a:p>
         </p:txBody>
@@ -13890,7 +14383,7 @@
                 </a:solidFill>
                 <a:latin typeface="Courier New"/>
               </a:rPr>
-              <a:t>NOT HYPOTHETICAL · THE RECEIPTS</a:t>
+              <a:t>REAL CASES · IN THE NEWS</a:t>
             </a:r>
           </a:p>
         </p:txBody>
@@ -14719,7 +15212,7 @@
                 </a:solidFill>
                 <a:latin typeface="Courier New"/>
               </a:rPr>
-              <a:t>NOT HYPOTHETICAL · THE RECEIPTS</a:t>
+              <a:t>REAL CASES · IN THE NEWS</a:t>
             </a:r>
           </a:p>
         </p:txBody>
@@ -15548,7 +16041,7 @@
                 </a:solidFill>
                 <a:latin typeface="Courier New"/>
               </a:rPr>
-              <a:t>NOT HYPOTHETICAL · PRIVACY</a:t>
+              <a:t>REAL CASES · PRIVACY</a:t>
             </a:r>
           </a:p>
         </p:txBody>

</xml_diff>